<commit_message>
Use real photos for all 8 slides (except hero SVG)
- Slide 4 (Paulus): desert_paulus.jpg — Wüste bei Nacht, Person mit Fackel = Missionsreise
- Slide 6 (Konstantin): colosseum_real.jpg — Kolosseum bei Nacht = Herz des Reiches
- Slide 7 (Wende): cathedral_wende.jpg — rot-beleuchteter Dom = Kirche mit Staatsmacht
- Slide 8 (Erbe): great_wall_erbe.jpg — Chinesische Mauer Sonnenuntergang = historisches Erbe
- Dark overlay (addBgPhoto) angepasst je nach Helligkeit des Fotos (38–55% transparency)
- Alle SVG-Hintergründe bis auf forum.jpg (Startfolie) ersetzt

https://claude.ai/code/session_013TBMzPSrUf2jGzKeLXb52a
</commit_message>
<xml_diff>
--- a/Anfaenge_Kirche_Antike_v3.pptx
+++ b/Anfaenge_Kirche_Antike_v3.pptx
@@ -5249,7 +5249,7 @@
       </p:grpSpPr>
       <p:pic>
         <p:nvPicPr>
-          <p:cNvPr id="2" name="Image 0" descr="/home/user/uwg_raesfeld_erle_website_repo/images_v3/ostia.jpg">    </p:cNvPr>
+          <p:cNvPr id="2" name="Image 0" descr="/home/user/uwg_raesfeld_erle_website_repo/images_v3/desert_paulus.jpg">    </p:cNvPr>
           <p:cNvPicPr>
             <a:picLocks noChangeAspect="1"/>
           </p:cNvPicPr>
@@ -5270,9 +5270,38 @@
           </a:prstGeom>
         </p:spPr>
       </p:pic>
+      <p:sp>
+        <p:nvSpPr>
+          <p:cNvPr id="3" name="Shape 0"/>
+          <p:cNvSpPr/>
+          <p:nvPr/>
+        </p:nvSpPr>
+        <p:spPr>
+          <a:xfrm>
+            <a:off x="0" y="0"/>
+            <a:ext cx="12191695" cy="6858000"/>
+          </a:xfrm>
+          <a:prstGeom prst="rect">
+            <a:avLst/>
+          </a:prstGeom>
+          <a:solidFill>
+            <a:srgbClr val="000000">
+              <a:alpha val="45000"/>
+            </a:srgbClr>
+          </a:solidFill>
+          <a:ln w="12700">
+            <a:solidFill>
+              <a:srgbClr val="000000">
+                <a:alpha val="0"/>
+              </a:srgbClr>
+            </a:solidFill>
+            <a:prstDash val="solid"/>
+          </a:ln>
+        </p:spPr>
+      </p:sp>
       <p:pic>
         <p:nvPicPr>
-          <p:cNvPr id="3" name="Image 1" descr="preencoded.png">    </p:cNvPr>
+          <p:cNvPr id="4" name="Image 1" descr="preencoded.png">    </p:cNvPr>
           <p:cNvPicPr>
             <a:picLocks noChangeAspect="1"/>
           </p:cNvPicPr>
@@ -5302,7 +5331,7 @@
       </p:pic>
       <p:pic>
         <p:nvPicPr>
-          <p:cNvPr id="4" name="Image 2" descr="preencoded.png">    </p:cNvPr>
+          <p:cNvPr id="5" name="Image 2" descr="preencoded.png">    </p:cNvPr>
           <p:cNvPicPr>
             <a:picLocks noChangeAspect="1"/>
           </p:cNvPicPr>
@@ -5332,7 +5361,7 @@
       </p:pic>
       <p:pic>
         <p:nvPicPr>
-          <p:cNvPr id="5" name="Image 3" descr="preencoded.png">    </p:cNvPr>
+          <p:cNvPr id="6" name="Image 3" descr="preencoded.png">    </p:cNvPr>
           <p:cNvPicPr>
             <a:picLocks noChangeAspect="1"/>
           </p:cNvPicPr>
@@ -5362,7 +5391,7 @@
       </p:pic>
       <p:sp>
         <p:nvSpPr>
-          <p:cNvPr id="6" name="Text 0"/>
+          <p:cNvPr id="7" name="Text 1"/>
           <p:cNvSpPr/>
           <p:nvPr/>
         </p:nvSpPr>
@@ -5408,7 +5437,7 @@
       </p:sp>
       <p:pic>
         <p:nvPicPr>
-          <p:cNvPr id="7" name="Image 4" descr="preencoded.png">    </p:cNvPr>
+          <p:cNvPr id="8" name="Image 4" descr="preencoded.png">    </p:cNvPr>
           <p:cNvPicPr>
             <a:picLocks noChangeAspect="1"/>
           </p:cNvPicPr>
@@ -5438,7 +5467,7 @@
       </p:pic>
       <p:sp>
         <p:nvSpPr>
-          <p:cNvPr id="8" name="Text 1"/>
+          <p:cNvPr id="9" name="Text 2"/>
           <p:cNvSpPr/>
           <p:nvPr/>
         </p:nvSpPr>
@@ -5480,7 +5509,7 @@
       </p:sp>
       <p:sp>
         <p:nvSpPr>
-          <p:cNvPr id="9" name="Text 2"/>
+          <p:cNvPr id="10" name="Text 3"/>
           <p:cNvSpPr/>
           <p:nvPr/>
         </p:nvSpPr>
@@ -5519,7 +5548,7 @@
       </p:sp>
       <p:sp>
         <p:nvSpPr>
-          <p:cNvPr id="10" name="Shape 3"/>
+          <p:cNvPr id="11" name="Shape 4"/>
           <p:cNvSpPr/>
           <p:nvPr/>
         </p:nvSpPr>
@@ -5548,7 +5577,7 @@
       </p:sp>
       <p:sp>
         <p:nvSpPr>
-          <p:cNvPr id="11" name="Shape 4"/>
+          <p:cNvPr id="12" name="Shape 5"/>
           <p:cNvSpPr/>
           <p:nvPr/>
         </p:nvSpPr>
@@ -5570,7 +5599,7 @@
       </p:sp>
       <p:sp>
         <p:nvSpPr>
-          <p:cNvPr id="12" name="Text 5"/>
+          <p:cNvPr id="13" name="Text 6"/>
           <p:cNvSpPr/>
           <p:nvPr/>
         </p:nvSpPr>
@@ -5609,7 +5638,7 @@
       </p:sp>
       <p:sp>
         <p:nvSpPr>
-          <p:cNvPr id="13" name="Text 6"/>
+          <p:cNvPr id="14" name="Text 7"/>
           <p:cNvSpPr/>
           <p:nvPr/>
         </p:nvSpPr>
@@ -5691,7 +5720,7 @@
       </p:sp>
       <p:sp>
         <p:nvSpPr>
-          <p:cNvPr id="14" name="Text 7"/>
+          <p:cNvPr id="15" name="Text 8"/>
           <p:cNvSpPr/>
           <p:nvPr/>
         </p:nvSpPr>
@@ -5730,7 +5759,7 @@
       </p:sp>
       <p:pic>
         <p:nvPicPr>
-          <p:cNvPr id="15" name="Image 5" descr="preencoded.png">    </p:cNvPr>
+          <p:cNvPr id="16" name="Image 5" descr="preencoded.png">    </p:cNvPr>
           <p:cNvPicPr>
             <a:picLocks noChangeAspect="1"/>
           </p:cNvPicPr>
@@ -5760,7 +5789,7 @@
       </p:pic>
       <p:sp>
         <p:nvSpPr>
-          <p:cNvPr id="16" name="Shape 8"/>
+          <p:cNvPr id="17" name="Shape 9"/>
           <p:cNvSpPr/>
           <p:nvPr/>
         </p:nvSpPr>
@@ -5783,7 +5812,7 @@
       </p:sp>
       <p:sp>
         <p:nvSpPr>
-          <p:cNvPr id="17" name="Text 9"/>
+          <p:cNvPr id="18" name="Text 10"/>
           <p:cNvSpPr/>
           <p:nvPr/>
         </p:nvSpPr>
@@ -5822,7 +5851,7 @@
       </p:sp>
       <p:sp>
         <p:nvSpPr>
-          <p:cNvPr id="18" name="Text 10"/>
+          <p:cNvPr id="19" name="Text 11"/>
           <p:cNvSpPr/>
           <p:nvPr/>
         </p:nvSpPr>
@@ -5864,7 +5893,7 @@
       </p:sp>
       <p:pic>
         <p:nvPicPr>
-          <p:cNvPr id="19" name="Image 6" descr="preencoded.png">    </p:cNvPr>
+          <p:cNvPr id="20" name="Image 6" descr="preencoded.png">    </p:cNvPr>
           <p:cNvPicPr>
             <a:picLocks noChangeAspect="1"/>
           </p:cNvPicPr>
@@ -5894,7 +5923,7 @@
       </p:pic>
       <p:sp>
         <p:nvSpPr>
-          <p:cNvPr id="20" name="Shape 11"/>
+          <p:cNvPr id="21" name="Shape 12"/>
           <p:cNvSpPr/>
           <p:nvPr/>
         </p:nvSpPr>
@@ -5917,7 +5946,7 @@
       </p:sp>
       <p:sp>
         <p:nvSpPr>
-          <p:cNvPr id="21" name="Text 12"/>
+          <p:cNvPr id="22" name="Text 13"/>
           <p:cNvSpPr/>
           <p:nvPr/>
         </p:nvSpPr>
@@ -5956,7 +5985,7 @@
       </p:sp>
       <p:sp>
         <p:nvSpPr>
-          <p:cNvPr id="22" name="Text 13"/>
+          <p:cNvPr id="23" name="Text 14"/>
           <p:cNvSpPr/>
           <p:nvPr/>
         </p:nvSpPr>
@@ -5998,7 +6027,7 @@
       </p:sp>
       <p:pic>
         <p:nvPicPr>
-          <p:cNvPr id="23" name="Image 7" descr="preencoded.png">    </p:cNvPr>
+          <p:cNvPr id="24" name="Image 7" descr="preencoded.png">    </p:cNvPr>
           <p:cNvPicPr>
             <a:picLocks noChangeAspect="1"/>
           </p:cNvPicPr>
@@ -6028,7 +6057,7 @@
       </p:pic>
       <p:sp>
         <p:nvSpPr>
-          <p:cNvPr id="24" name="Shape 14"/>
+          <p:cNvPr id="25" name="Shape 15"/>
           <p:cNvSpPr/>
           <p:nvPr/>
         </p:nvSpPr>
@@ -6051,7 +6080,7 @@
       </p:sp>
       <p:sp>
         <p:nvSpPr>
-          <p:cNvPr id="25" name="Text 15"/>
+          <p:cNvPr id="26" name="Text 16"/>
           <p:cNvSpPr/>
           <p:nvPr/>
         </p:nvSpPr>
@@ -6090,7 +6119,7 @@
       </p:sp>
       <p:sp>
         <p:nvSpPr>
-          <p:cNvPr id="26" name="Text 16"/>
+          <p:cNvPr id="27" name="Text 17"/>
           <p:cNvSpPr/>
           <p:nvPr/>
         </p:nvSpPr>
@@ -6132,7 +6161,7 @@
       </p:sp>
       <p:pic>
         <p:nvPicPr>
-          <p:cNvPr id="27" name="Image 8" descr="preencoded.png">    </p:cNvPr>
+          <p:cNvPr id="28" name="Image 8" descr="preencoded.png">    </p:cNvPr>
           <p:cNvPicPr>
             <a:picLocks noChangeAspect="1"/>
           </p:cNvPicPr>
@@ -6162,7 +6191,7 @@
       </p:pic>
       <p:sp>
         <p:nvSpPr>
-          <p:cNvPr id="28" name="Shape 17"/>
+          <p:cNvPr id="29" name="Shape 18"/>
           <p:cNvSpPr/>
           <p:nvPr/>
         </p:nvSpPr>
@@ -6185,7 +6214,7 @@
       </p:sp>
       <p:sp>
         <p:nvSpPr>
-          <p:cNvPr id="29" name="Text 18"/>
+          <p:cNvPr id="30" name="Text 19"/>
           <p:cNvSpPr/>
           <p:nvPr/>
         </p:nvSpPr>
@@ -6224,7 +6253,7 @@
       </p:sp>
       <p:sp>
         <p:nvSpPr>
-          <p:cNvPr id="30" name="Text 19"/>
+          <p:cNvPr id="31" name="Text 20"/>
           <p:cNvSpPr/>
           <p:nvPr/>
         </p:nvSpPr>
@@ -6266,7 +6295,7 @@
       </p:sp>
       <p:pic>
         <p:nvPicPr>
-          <p:cNvPr id="31" name="Image 9" descr="preencoded.png">    </p:cNvPr>
+          <p:cNvPr id="32" name="Image 9" descr="preencoded.png">    </p:cNvPr>
           <p:cNvPicPr>
             <a:picLocks noChangeAspect="1"/>
           </p:cNvPicPr>
@@ -6296,7 +6325,7 @@
       </p:pic>
       <p:sp>
         <p:nvSpPr>
-          <p:cNvPr id="32" name="Text 20"/>
+          <p:cNvPr id="33" name="Text 21"/>
           <p:cNvSpPr/>
           <p:nvPr/>
         </p:nvSpPr>
@@ -6335,7 +6364,7 @@
       </p:sp>
       <p:sp>
         <p:nvSpPr>
-          <p:cNvPr id="33" name="Text 21"/>
+          <p:cNvPr id="34" name="Text 22"/>
           <p:cNvSpPr/>
           <p:nvPr/>
         </p:nvSpPr>
@@ -7598,7 +7627,7 @@
       </p:grpSpPr>
       <p:pic>
         <p:nvPicPr>
-          <p:cNvPr id="2" name="Image 0" descr="/home/user/uwg_raesfeld_erle_website_repo/images_v3/constantine_arch.jpg">    </p:cNvPr>
+          <p:cNvPr id="2" name="Image 0" descr="/home/user/uwg_raesfeld_erle_website_repo/images_v3/colosseum_real.jpg">    </p:cNvPr>
           <p:cNvPicPr>
             <a:picLocks noChangeAspect="1"/>
           </p:cNvPicPr>
@@ -7619,9 +7648,38 @@
           </a:prstGeom>
         </p:spPr>
       </p:pic>
+      <p:sp>
+        <p:nvSpPr>
+          <p:cNvPr id="3" name="Shape 0"/>
+          <p:cNvSpPr/>
+          <p:nvPr/>
+        </p:nvSpPr>
+        <p:spPr>
+          <a:xfrm>
+            <a:off x="0" y="0"/>
+            <a:ext cx="12191695" cy="6858000"/>
+          </a:xfrm>
+          <a:prstGeom prst="rect">
+            <a:avLst/>
+          </a:prstGeom>
+          <a:solidFill>
+            <a:srgbClr val="000000">
+              <a:alpha val="48000"/>
+            </a:srgbClr>
+          </a:solidFill>
+          <a:ln w="12700">
+            <a:solidFill>
+              <a:srgbClr val="000000">
+                <a:alpha val="0"/>
+              </a:srgbClr>
+            </a:solidFill>
+            <a:prstDash val="solid"/>
+          </a:ln>
+        </p:spPr>
+      </p:sp>
       <p:pic>
         <p:nvPicPr>
-          <p:cNvPr id="3" name="Image 1" descr="preencoded.png">    </p:cNvPr>
+          <p:cNvPr id="4" name="Image 1" descr="preencoded.png">    </p:cNvPr>
           <p:cNvPicPr>
             <a:picLocks noChangeAspect="1"/>
           </p:cNvPicPr>
@@ -7651,7 +7709,7 @@
       </p:pic>
       <p:pic>
         <p:nvPicPr>
-          <p:cNvPr id="4" name="Image 2" descr="preencoded.png">    </p:cNvPr>
+          <p:cNvPr id="5" name="Image 2" descr="preencoded.png">    </p:cNvPr>
           <p:cNvPicPr>
             <a:picLocks noChangeAspect="1"/>
           </p:cNvPicPr>
@@ -7681,7 +7739,7 @@
       </p:pic>
       <p:pic>
         <p:nvPicPr>
-          <p:cNvPr id="5" name="Image 3" descr="preencoded.png">    </p:cNvPr>
+          <p:cNvPr id="6" name="Image 3" descr="preencoded.png">    </p:cNvPr>
           <p:cNvPicPr>
             <a:picLocks noChangeAspect="1"/>
           </p:cNvPicPr>
@@ -7711,7 +7769,7 @@
       </p:pic>
       <p:sp>
         <p:nvSpPr>
-          <p:cNvPr id="6" name="Text 0"/>
+          <p:cNvPr id="7" name="Text 1"/>
           <p:cNvSpPr/>
           <p:nvPr/>
         </p:nvSpPr>
@@ -7791,7 +7849,7 @@
       </p:sp>
       <p:sp>
         <p:nvSpPr>
-          <p:cNvPr id="7" name="Text 1"/>
+          <p:cNvPr id="8" name="Text 2"/>
           <p:cNvSpPr/>
           <p:nvPr/>
         </p:nvSpPr>
@@ -7853,7 +7911,7 @@
       </p:sp>
       <p:sp>
         <p:nvSpPr>
-          <p:cNvPr id="8" name="Shape 2"/>
+          <p:cNvPr id="9" name="Shape 3"/>
           <p:cNvSpPr/>
           <p:nvPr/>
         </p:nvSpPr>
@@ -7882,7 +7940,7 @@
       </p:sp>
       <p:sp>
         <p:nvSpPr>
-          <p:cNvPr id="9" name="Shape 3"/>
+          <p:cNvPr id="10" name="Shape 4"/>
           <p:cNvSpPr/>
           <p:nvPr/>
         </p:nvSpPr>
@@ -7904,7 +7962,7 @@
       </p:sp>
       <p:sp>
         <p:nvSpPr>
-          <p:cNvPr id="10" name="Text 4"/>
+          <p:cNvPr id="11" name="Text 5"/>
           <p:cNvSpPr/>
           <p:nvPr/>
         </p:nvSpPr>
@@ -7943,7 +8001,7 @@
       </p:sp>
       <p:sp>
         <p:nvSpPr>
-          <p:cNvPr id="11" name="Text 5"/>
+          <p:cNvPr id="12" name="Text 6"/>
           <p:cNvSpPr/>
           <p:nvPr/>
         </p:nvSpPr>
@@ -7985,7 +8043,7 @@
       </p:sp>
       <p:sp>
         <p:nvSpPr>
-          <p:cNvPr id="12" name="Text 6"/>
+          <p:cNvPr id="13" name="Text 7"/>
           <p:cNvSpPr/>
           <p:nvPr/>
         </p:nvSpPr>
@@ -8024,7 +8082,7 @@
       </p:sp>
       <p:sp>
         <p:nvSpPr>
-          <p:cNvPr id="13" name="Shape 7"/>
+          <p:cNvPr id="14" name="Shape 8"/>
           <p:cNvSpPr/>
           <p:nvPr/>
         </p:nvSpPr>
@@ -8060,7 +8118,7 @@
       </p:sp>
       <p:sp>
         <p:nvSpPr>
-          <p:cNvPr id="14" name="Shape 8"/>
+          <p:cNvPr id="15" name="Shape 9"/>
           <p:cNvSpPr/>
           <p:nvPr/>
         </p:nvSpPr>
@@ -8082,7 +8140,7 @@
       </p:sp>
       <p:sp>
         <p:nvSpPr>
-          <p:cNvPr id="15" name="Text 9"/>
+          <p:cNvPr id="16" name="Text 10"/>
           <p:cNvSpPr/>
           <p:nvPr/>
         </p:nvSpPr>
@@ -8128,7 +8186,7 @@
       </p:sp>
       <p:sp>
         <p:nvSpPr>
-          <p:cNvPr id="16" name="Text 10"/>
+          <p:cNvPr id="17" name="Text 11"/>
           <p:cNvSpPr/>
           <p:nvPr/>
         </p:nvSpPr>
@@ -8167,7 +8225,7 @@
       </p:sp>
       <p:pic>
         <p:nvPicPr>
-          <p:cNvPr id="17" name="Image 4" descr="preencoded.png">    </p:cNvPr>
+          <p:cNvPr id="18" name="Image 4" descr="preencoded.png">    </p:cNvPr>
           <p:cNvPicPr>
             <a:picLocks noChangeAspect="1"/>
           </p:cNvPicPr>
@@ -8197,7 +8255,7 @@
       </p:pic>
       <p:sp>
         <p:nvSpPr>
-          <p:cNvPr id="18" name="Text 11"/>
+          <p:cNvPr id="19" name="Text 12"/>
           <p:cNvSpPr/>
           <p:nvPr/>
         </p:nvSpPr>
@@ -8239,7 +8297,7 @@
       </p:sp>
       <p:sp>
         <p:nvSpPr>
-          <p:cNvPr id="19" name="Shape 12"/>
+          <p:cNvPr id="20" name="Shape 13"/>
           <p:cNvSpPr/>
           <p:nvPr/>
         </p:nvSpPr>
@@ -8275,7 +8333,7 @@
       </p:sp>
       <p:sp>
         <p:nvSpPr>
-          <p:cNvPr id="20" name="Shape 13"/>
+          <p:cNvPr id="21" name="Shape 14"/>
           <p:cNvSpPr/>
           <p:nvPr/>
         </p:nvSpPr>
@@ -8297,7 +8355,7 @@
       </p:sp>
       <p:sp>
         <p:nvSpPr>
-          <p:cNvPr id="21" name="Text 14"/>
+          <p:cNvPr id="22" name="Text 15"/>
           <p:cNvSpPr/>
           <p:nvPr/>
         </p:nvSpPr>
@@ -8343,7 +8401,7 @@
       </p:sp>
       <p:sp>
         <p:nvSpPr>
-          <p:cNvPr id="22" name="Text 15"/>
+          <p:cNvPr id="23" name="Text 16"/>
           <p:cNvSpPr/>
           <p:nvPr/>
         </p:nvSpPr>
@@ -8382,7 +8440,7 @@
       </p:sp>
       <p:pic>
         <p:nvPicPr>
-          <p:cNvPr id="23" name="Image 5" descr="preencoded.png">    </p:cNvPr>
+          <p:cNvPr id="24" name="Image 5" descr="preencoded.png">    </p:cNvPr>
           <p:cNvPicPr>
             <a:picLocks noChangeAspect="1"/>
           </p:cNvPicPr>
@@ -8412,7 +8470,7 @@
       </p:pic>
       <p:sp>
         <p:nvSpPr>
-          <p:cNvPr id="24" name="Text 16"/>
+          <p:cNvPr id="25" name="Text 17"/>
           <p:cNvSpPr/>
           <p:nvPr/>
         </p:nvSpPr>
@@ -8454,7 +8512,7 @@
       </p:sp>
       <p:sp>
         <p:nvSpPr>
-          <p:cNvPr id="25" name="Shape 17"/>
+          <p:cNvPr id="26" name="Shape 18"/>
           <p:cNvSpPr/>
           <p:nvPr/>
         </p:nvSpPr>
@@ -8490,7 +8548,7 @@
       </p:sp>
       <p:sp>
         <p:nvSpPr>
-          <p:cNvPr id="26" name="Shape 18"/>
+          <p:cNvPr id="27" name="Shape 19"/>
           <p:cNvSpPr/>
           <p:nvPr/>
         </p:nvSpPr>
@@ -8512,7 +8570,7 @@
       </p:sp>
       <p:sp>
         <p:nvSpPr>
-          <p:cNvPr id="27" name="Text 19"/>
+          <p:cNvPr id="28" name="Text 20"/>
           <p:cNvSpPr/>
           <p:nvPr/>
         </p:nvSpPr>
@@ -8558,7 +8616,7 @@
       </p:sp>
       <p:sp>
         <p:nvSpPr>
-          <p:cNvPr id="28" name="Text 20"/>
+          <p:cNvPr id="29" name="Text 21"/>
           <p:cNvSpPr/>
           <p:nvPr/>
         </p:nvSpPr>
@@ -8597,7 +8655,7 @@
       </p:sp>
       <p:pic>
         <p:nvPicPr>
-          <p:cNvPr id="29" name="Image 6" descr="preencoded.png">    </p:cNvPr>
+          <p:cNvPr id="30" name="Image 6" descr="preencoded.png">    </p:cNvPr>
           <p:cNvPicPr>
             <a:picLocks noChangeAspect="1"/>
           </p:cNvPicPr>
@@ -8627,7 +8685,7 @@
       </p:pic>
       <p:sp>
         <p:nvSpPr>
-          <p:cNvPr id="30" name="Text 21"/>
+          <p:cNvPr id="31" name="Text 22"/>
           <p:cNvSpPr/>
           <p:nvPr/>
         </p:nvSpPr>
@@ -8669,7 +8727,7 @@
       </p:sp>
       <p:pic>
         <p:nvPicPr>
-          <p:cNvPr id="31" name="Image 7" descr="preencoded.png">    </p:cNvPr>
+          <p:cNvPr id="32" name="Image 7" descr="preencoded.png">    </p:cNvPr>
           <p:cNvPicPr>
             <a:picLocks noChangeAspect="1"/>
           </p:cNvPicPr>
@@ -8699,7 +8757,7 @@
       </p:pic>
       <p:sp>
         <p:nvSpPr>
-          <p:cNvPr id="32" name="Text 22"/>
+          <p:cNvPr id="33" name="Text 23"/>
           <p:cNvSpPr/>
           <p:nvPr/>
         </p:nvSpPr>
@@ -8763,7 +8821,7 @@
       </p:grpSpPr>
       <p:pic>
         <p:nvPicPr>
-          <p:cNvPr id="2" name="Image 0" descr="/home/user/uwg_raesfeld_erle_website_repo/images_v3/hagia_sophia.jpg">    </p:cNvPr>
+          <p:cNvPr id="2" name="Image 0" descr="/home/user/uwg_raesfeld_erle_website_repo/images_v3/cathedral_wende.jpg">    </p:cNvPr>
           <p:cNvPicPr>
             <a:picLocks noChangeAspect="1"/>
           </p:cNvPicPr>
@@ -8784,9 +8842,38 @@
           </a:prstGeom>
         </p:spPr>
       </p:pic>
+      <p:sp>
+        <p:nvSpPr>
+          <p:cNvPr id="3" name="Shape 0"/>
+          <p:cNvSpPr/>
+          <p:nvPr/>
+        </p:nvSpPr>
+        <p:spPr>
+          <a:xfrm>
+            <a:off x="0" y="0"/>
+            <a:ext cx="12191695" cy="6858000"/>
+          </a:xfrm>
+          <a:prstGeom prst="rect">
+            <a:avLst/>
+          </a:prstGeom>
+          <a:solidFill>
+            <a:srgbClr val="000000">
+              <a:alpha val="45000"/>
+            </a:srgbClr>
+          </a:solidFill>
+          <a:ln w="12700">
+            <a:solidFill>
+              <a:srgbClr val="000000">
+                <a:alpha val="0"/>
+              </a:srgbClr>
+            </a:solidFill>
+            <a:prstDash val="solid"/>
+          </a:ln>
+        </p:spPr>
+      </p:sp>
       <p:pic>
         <p:nvPicPr>
-          <p:cNvPr id="3" name="Image 1" descr="preencoded.png">    </p:cNvPr>
+          <p:cNvPr id="4" name="Image 1" descr="preencoded.png">    </p:cNvPr>
           <p:cNvPicPr>
             <a:picLocks noChangeAspect="1"/>
           </p:cNvPicPr>
@@ -8816,7 +8903,7 @@
       </p:pic>
       <p:pic>
         <p:nvPicPr>
-          <p:cNvPr id="4" name="Image 2" descr="preencoded.png">    </p:cNvPr>
+          <p:cNvPr id="5" name="Image 2" descr="preencoded.png">    </p:cNvPr>
           <p:cNvPicPr>
             <a:picLocks noChangeAspect="1"/>
           </p:cNvPicPr>
@@ -8846,7 +8933,7 @@
       </p:pic>
       <p:pic>
         <p:nvPicPr>
-          <p:cNvPr id="5" name="Image 3" descr="preencoded.png">    </p:cNvPr>
+          <p:cNvPr id="6" name="Image 3" descr="preencoded.png">    </p:cNvPr>
           <p:cNvPicPr>
             <a:picLocks noChangeAspect="1"/>
           </p:cNvPicPr>
@@ -8876,7 +8963,7 @@
       </p:pic>
       <p:sp>
         <p:nvSpPr>
-          <p:cNvPr id="6" name="Text 0"/>
+          <p:cNvPr id="7" name="Text 1"/>
           <p:cNvSpPr/>
           <p:nvPr/>
         </p:nvSpPr>
@@ -8922,7 +9009,7 @@
       </p:sp>
       <p:sp>
         <p:nvSpPr>
-          <p:cNvPr id="7" name="Text 1"/>
+          <p:cNvPr id="8" name="Text 2"/>
           <p:cNvSpPr/>
           <p:nvPr/>
         </p:nvSpPr>
@@ -8985,7 +9072,7 @@
       </p:sp>
       <p:pic>
         <p:nvPicPr>
-          <p:cNvPr id="8" name="Image 4" descr="preencoded.png">    </p:cNvPr>
+          <p:cNvPr id="9" name="Image 4" descr="preencoded.png">    </p:cNvPr>
           <p:cNvPicPr>
             <a:picLocks noChangeAspect="1"/>
           </p:cNvPicPr>
@@ -9015,7 +9102,7 @@
       </p:pic>
       <p:sp>
         <p:nvSpPr>
-          <p:cNvPr id="9" name="Text 2"/>
+          <p:cNvPr id="10" name="Text 3"/>
           <p:cNvSpPr/>
           <p:nvPr/>
         </p:nvSpPr>
@@ -9057,7 +9144,7 @@
       </p:sp>
       <p:sp>
         <p:nvSpPr>
-          <p:cNvPr id="10" name="Shape 3"/>
+          <p:cNvPr id="11" name="Shape 4"/>
           <p:cNvSpPr/>
           <p:nvPr/>
         </p:nvSpPr>
@@ -9086,7 +9173,7 @@
       </p:sp>
       <p:sp>
         <p:nvSpPr>
-          <p:cNvPr id="11" name="Shape 4"/>
+          <p:cNvPr id="12" name="Shape 5"/>
           <p:cNvSpPr/>
           <p:nvPr/>
         </p:nvSpPr>
@@ -9108,7 +9195,7 @@
       </p:sp>
       <p:sp>
         <p:nvSpPr>
-          <p:cNvPr id="12" name="Text 5"/>
+          <p:cNvPr id="13" name="Text 6"/>
           <p:cNvSpPr/>
           <p:nvPr/>
         </p:nvSpPr>
@@ -9147,7 +9234,7 @@
       </p:sp>
       <p:sp>
         <p:nvSpPr>
-          <p:cNvPr id="13" name="Text 6"/>
+          <p:cNvPr id="14" name="Text 7"/>
           <p:cNvSpPr/>
           <p:nvPr/>
         </p:nvSpPr>
@@ -9189,7 +9276,7 @@
       </p:sp>
       <p:sp>
         <p:nvSpPr>
-          <p:cNvPr id="14" name="Text 7"/>
+          <p:cNvPr id="15" name="Text 8"/>
           <p:cNvSpPr/>
           <p:nvPr/>
         </p:nvSpPr>
@@ -9228,7 +9315,7 @@
       </p:sp>
       <p:pic>
         <p:nvPicPr>
-          <p:cNvPr id="15" name="Image 5" descr="preencoded.png">    </p:cNvPr>
+          <p:cNvPr id="16" name="Image 5" descr="preencoded.png">    </p:cNvPr>
           <p:cNvPicPr>
             <a:picLocks noChangeAspect="1"/>
           </p:cNvPicPr>
@@ -9258,7 +9345,7 @@
       </p:pic>
       <p:sp>
         <p:nvSpPr>
-          <p:cNvPr id="16" name="Shape 8"/>
+          <p:cNvPr id="17" name="Shape 9"/>
           <p:cNvSpPr/>
           <p:nvPr/>
         </p:nvSpPr>
@@ -9281,7 +9368,7 @@
       </p:sp>
       <p:sp>
         <p:nvSpPr>
-          <p:cNvPr id="17" name="Text 9"/>
+          <p:cNvPr id="18" name="Text 10"/>
           <p:cNvSpPr/>
           <p:nvPr/>
         </p:nvSpPr>
@@ -9320,7 +9407,7 @@
       </p:sp>
       <p:sp>
         <p:nvSpPr>
-          <p:cNvPr id="18" name="Text 10"/>
+          <p:cNvPr id="19" name="Text 11"/>
           <p:cNvSpPr/>
           <p:nvPr/>
         </p:nvSpPr>
@@ -9362,7 +9449,7 @@
       </p:sp>
       <p:pic>
         <p:nvPicPr>
-          <p:cNvPr id="19" name="Image 6" descr="preencoded.png">    </p:cNvPr>
+          <p:cNvPr id="20" name="Image 6" descr="preencoded.png">    </p:cNvPr>
           <p:cNvPicPr>
             <a:picLocks noChangeAspect="1"/>
           </p:cNvPicPr>
@@ -9392,7 +9479,7 @@
       </p:pic>
       <p:sp>
         <p:nvSpPr>
-          <p:cNvPr id="20" name="Shape 11"/>
+          <p:cNvPr id="21" name="Shape 12"/>
           <p:cNvSpPr/>
           <p:nvPr/>
         </p:nvSpPr>
@@ -9415,7 +9502,7 @@
       </p:sp>
       <p:sp>
         <p:nvSpPr>
-          <p:cNvPr id="21" name="Text 12"/>
+          <p:cNvPr id="22" name="Text 13"/>
           <p:cNvSpPr/>
           <p:nvPr/>
         </p:nvSpPr>
@@ -9454,7 +9541,7 @@
       </p:sp>
       <p:sp>
         <p:nvSpPr>
-          <p:cNvPr id="22" name="Text 13"/>
+          <p:cNvPr id="23" name="Text 14"/>
           <p:cNvSpPr/>
           <p:nvPr/>
         </p:nvSpPr>
@@ -9496,7 +9583,7 @@
       </p:sp>
       <p:pic>
         <p:nvPicPr>
-          <p:cNvPr id="23" name="Image 7" descr="preencoded.png">    </p:cNvPr>
+          <p:cNvPr id="24" name="Image 7" descr="preencoded.png">    </p:cNvPr>
           <p:cNvPicPr>
             <a:picLocks noChangeAspect="1"/>
           </p:cNvPicPr>
@@ -9526,7 +9613,7 @@
       </p:pic>
       <p:sp>
         <p:nvSpPr>
-          <p:cNvPr id="24" name="Shape 14"/>
+          <p:cNvPr id="25" name="Shape 15"/>
           <p:cNvSpPr/>
           <p:nvPr/>
         </p:nvSpPr>
@@ -9549,7 +9636,7 @@
       </p:sp>
       <p:sp>
         <p:nvSpPr>
-          <p:cNvPr id="25" name="Text 15"/>
+          <p:cNvPr id="26" name="Text 16"/>
           <p:cNvSpPr/>
           <p:nvPr/>
         </p:nvSpPr>
@@ -9588,7 +9675,7 @@
       </p:sp>
       <p:sp>
         <p:nvSpPr>
-          <p:cNvPr id="26" name="Text 16"/>
+          <p:cNvPr id="27" name="Text 17"/>
           <p:cNvSpPr/>
           <p:nvPr/>
         </p:nvSpPr>
@@ -9630,7 +9717,7 @@
       </p:sp>
       <p:pic>
         <p:nvPicPr>
-          <p:cNvPr id="27" name="Image 8" descr="preencoded.png">    </p:cNvPr>
+          <p:cNvPr id="28" name="Image 8" descr="preencoded.png">    </p:cNvPr>
           <p:cNvPicPr>
             <a:picLocks noChangeAspect="1"/>
           </p:cNvPicPr>
@@ -9660,7 +9747,7 @@
       </p:pic>
       <p:sp>
         <p:nvSpPr>
-          <p:cNvPr id="28" name="Shape 17"/>
+          <p:cNvPr id="29" name="Shape 18"/>
           <p:cNvSpPr/>
           <p:nvPr/>
         </p:nvSpPr>
@@ -9683,7 +9770,7 @@
       </p:sp>
       <p:sp>
         <p:nvSpPr>
-          <p:cNvPr id="29" name="Text 18"/>
+          <p:cNvPr id="30" name="Text 19"/>
           <p:cNvSpPr/>
           <p:nvPr/>
         </p:nvSpPr>
@@ -9722,7 +9809,7 @@
       </p:sp>
       <p:sp>
         <p:nvSpPr>
-          <p:cNvPr id="30" name="Text 19"/>
+          <p:cNvPr id="31" name="Text 20"/>
           <p:cNvSpPr/>
           <p:nvPr/>
         </p:nvSpPr>
@@ -9764,7 +9851,7 @@
       </p:sp>
       <p:pic>
         <p:nvPicPr>
-          <p:cNvPr id="31" name="Image 9" descr="preencoded.png">    </p:cNvPr>
+          <p:cNvPr id="32" name="Image 9" descr="preencoded.png">    </p:cNvPr>
           <p:cNvPicPr>
             <a:picLocks noChangeAspect="1"/>
           </p:cNvPicPr>
@@ -9794,7 +9881,7 @@
       </p:pic>
       <p:sp>
         <p:nvSpPr>
-          <p:cNvPr id="32" name="Shape 20"/>
+          <p:cNvPr id="33" name="Shape 21"/>
           <p:cNvSpPr/>
           <p:nvPr/>
         </p:nvSpPr>
@@ -9817,7 +9904,7 @@
       </p:sp>
       <p:sp>
         <p:nvSpPr>
-          <p:cNvPr id="33" name="Text 21"/>
+          <p:cNvPr id="34" name="Text 22"/>
           <p:cNvSpPr/>
           <p:nvPr/>
         </p:nvSpPr>
@@ -9856,7 +9943,7 @@
       </p:sp>
       <p:sp>
         <p:nvSpPr>
-          <p:cNvPr id="34" name="Text 22"/>
+          <p:cNvPr id="35" name="Text 23"/>
           <p:cNvSpPr/>
           <p:nvPr/>
         </p:nvSpPr>
@@ -9898,7 +9985,7 @@
       </p:sp>
       <p:pic>
         <p:nvPicPr>
-          <p:cNvPr id="35" name="Image 10" descr="preencoded.png">    </p:cNvPr>
+          <p:cNvPr id="36" name="Image 10" descr="preencoded.png">    </p:cNvPr>
           <p:cNvPicPr>
             <a:picLocks noChangeAspect="1"/>
           </p:cNvPicPr>
@@ -9928,7 +10015,7 @@
       </p:pic>
       <p:sp>
         <p:nvSpPr>
-          <p:cNvPr id="36" name="Shape 23"/>
+          <p:cNvPr id="37" name="Shape 24"/>
           <p:cNvSpPr/>
           <p:nvPr/>
         </p:nvSpPr>
@@ -9951,7 +10038,7 @@
       </p:sp>
       <p:sp>
         <p:nvSpPr>
-          <p:cNvPr id="37" name="Text 24"/>
+          <p:cNvPr id="38" name="Text 25"/>
           <p:cNvSpPr/>
           <p:nvPr/>
         </p:nvSpPr>
@@ -9990,7 +10077,7 @@
       </p:sp>
       <p:sp>
         <p:nvSpPr>
-          <p:cNvPr id="38" name="Text 25"/>
+          <p:cNvPr id="39" name="Text 26"/>
           <p:cNvSpPr/>
           <p:nvPr/>
         </p:nvSpPr>
@@ -10032,7 +10119,7 @@
       </p:sp>
       <p:pic>
         <p:nvPicPr>
-          <p:cNvPr id="39" name="Image 11" descr="preencoded.png">    </p:cNvPr>
+          <p:cNvPr id="40" name="Image 11" descr="preencoded.png">    </p:cNvPr>
           <p:cNvPicPr>
             <a:picLocks noChangeAspect="1"/>
           </p:cNvPicPr>
@@ -10062,7 +10149,7 @@
       </p:pic>
       <p:sp>
         <p:nvSpPr>
-          <p:cNvPr id="40" name="Text 26"/>
+          <p:cNvPr id="41" name="Text 27"/>
           <p:cNvSpPr/>
           <p:nvPr/>
         </p:nvSpPr>
@@ -10101,7 +10188,7 @@
       </p:sp>
       <p:sp>
         <p:nvSpPr>
-          <p:cNvPr id="41" name="Text 27"/>
+          <p:cNvPr id="42" name="Text 28"/>
           <p:cNvSpPr/>
           <p:nvPr/>
         </p:nvSpPr>
@@ -10168,7 +10255,7 @@
       </p:grpSpPr>
       <p:pic>
         <p:nvPicPr>
-          <p:cNvPr id="2" name="Image 0" descr="/home/user/uwg_raesfeld_erle_website_repo/images_v3/basilica.jpg">    </p:cNvPr>
+          <p:cNvPr id="2" name="Image 0" descr="/home/user/uwg_raesfeld_erle_website_repo/images_v3/great_wall_erbe.jpg">    </p:cNvPr>
           <p:cNvPicPr>
             <a:picLocks noChangeAspect="1"/>
           </p:cNvPicPr>
@@ -10189,9 +10276,38 @@
           </a:prstGeom>
         </p:spPr>
       </p:pic>
+      <p:sp>
+        <p:nvSpPr>
+          <p:cNvPr id="3" name="Shape 0"/>
+          <p:cNvSpPr/>
+          <p:nvPr/>
+        </p:nvSpPr>
+        <p:spPr>
+          <a:xfrm>
+            <a:off x="0" y="0"/>
+            <a:ext cx="12191695" cy="6858000"/>
+          </a:xfrm>
+          <a:prstGeom prst="rect">
+            <a:avLst/>
+          </a:prstGeom>
+          <a:solidFill>
+            <a:srgbClr val="000000">
+              <a:alpha val="62000"/>
+            </a:srgbClr>
+          </a:solidFill>
+          <a:ln w="12700">
+            <a:solidFill>
+              <a:srgbClr val="000000">
+                <a:alpha val="0"/>
+              </a:srgbClr>
+            </a:solidFill>
+            <a:prstDash val="solid"/>
+          </a:ln>
+        </p:spPr>
+      </p:sp>
       <p:pic>
         <p:nvPicPr>
-          <p:cNvPr id="3" name="Image 1" descr="preencoded.png">    </p:cNvPr>
+          <p:cNvPr id="4" name="Image 1" descr="preencoded.png">    </p:cNvPr>
           <p:cNvPicPr>
             <a:picLocks noChangeAspect="1"/>
           </p:cNvPicPr>
@@ -10221,7 +10337,7 @@
       </p:pic>
       <p:pic>
         <p:nvPicPr>
-          <p:cNvPr id="4" name="Image 2" descr="preencoded.png">    </p:cNvPr>
+          <p:cNvPr id="5" name="Image 2" descr="preencoded.png">    </p:cNvPr>
           <p:cNvPicPr>
             <a:picLocks noChangeAspect="1"/>
           </p:cNvPicPr>
@@ -10251,7 +10367,7 @@
       </p:pic>
       <p:pic>
         <p:nvPicPr>
-          <p:cNvPr id="5" name="Image 3" descr="preencoded.png">    </p:cNvPr>
+          <p:cNvPr id="6" name="Image 3" descr="preencoded.png">    </p:cNvPr>
           <p:cNvPicPr>
             <a:picLocks noChangeAspect="1"/>
           </p:cNvPicPr>
@@ -10281,7 +10397,7 @@
       </p:pic>
       <p:pic>
         <p:nvPicPr>
-          <p:cNvPr id="6" name="Image 4" descr="preencoded.png">    </p:cNvPr>
+          <p:cNvPr id="7" name="Image 4" descr="preencoded.png">    </p:cNvPr>
           <p:cNvPicPr>
             <a:picLocks noChangeAspect="1"/>
           </p:cNvPicPr>
@@ -10311,7 +10427,7 @@
       </p:pic>
       <p:sp>
         <p:nvSpPr>
-          <p:cNvPr id="7" name="Shape 0"/>
+          <p:cNvPr id="8" name="Shape 1"/>
           <p:cNvSpPr/>
           <p:nvPr/>
         </p:nvSpPr>
@@ -10340,7 +10456,7 @@
       </p:sp>
       <p:sp>
         <p:nvSpPr>
-          <p:cNvPr id="8" name="Shape 1"/>
+          <p:cNvPr id="9" name="Shape 2"/>
           <p:cNvSpPr/>
           <p:nvPr/>
         </p:nvSpPr>
@@ -10362,7 +10478,7 @@
       </p:sp>
       <p:sp>
         <p:nvSpPr>
-          <p:cNvPr id="9" name="Shape 2"/>
+          <p:cNvPr id="10" name="Shape 3"/>
           <p:cNvSpPr/>
           <p:nvPr/>
         </p:nvSpPr>
@@ -10384,7 +10500,7 @@
       </p:sp>
       <p:pic>
         <p:nvPicPr>
-          <p:cNvPr id="10" name="Image 5" descr="preencoded.png">    </p:cNvPr>
+          <p:cNvPr id="11" name="Image 5" descr="preencoded.png">    </p:cNvPr>
           <p:cNvPicPr>
             <a:picLocks noChangeAspect="1"/>
           </p:cNvPicPr>
@@ -10414,7 +10530,7 @@
       </p:pic>
       <p:sp>
         <p:nvSpPr>
-          <p:cNvPr id="11" name="Text 3"/>
+          <p:cNvPr id="12" name="Text 4"/>
           <p:cNvSpPr/>
           <p:nvPr/>
         </p:nvSpPr>
@@ -10453,7 +10569,7 @@
       </p:sp>
       <p:sp>
         <p:nvSpPr>
-          <p:cNvPr id="12" name="Text 4"/>
+          <p:cNvPr id="13" name="Text 5"/>
           <p:cNvSpPr/>
           <p:nvPr/>
         </p:nvSpPr>
@@ -10495,7 +10611,7 @@
       </p:sp>
       <p:sp>
         <p:nvSpPr>
-          <p:cNvPr id="13" name="Shape 5"/>
+          <p:cNvPr id="14" name="Shape 6"/>
           <p:cNvSpPr/>
           <p:nvPr/>
         </p:nvSpPr>
@@ -10524,7 +10640,7 @@
       </p:sp>
       <p:sp>
         <p:nvSpPr>
-          <p:cNvPr id="14" name="Shape 6"/>
+          <p:cNvPr id="15" name="Shape 7"/>
           <p:cNvSpPr/>
           <p:nvPr/>
         </p:nvSpPr>
@@ -10546,7 +10662,7 @@
       </p:sp>
       <p:sp>
         <p:nvSpPr>
-          <p:cNvPr id="15" name="Shape 7"/>
+          <p:cNvPr id="16" name="Shape 8"/>
           <p:cNvSpPr/>
           <p:nvPr/>
         </p:nvSpPr>
@@ -10568,7 +10684,7 @@
       </p:sp>
       <p:pic>
         <p:nvPicPr>
-          <p:cNvPr id="16" name="Image 6" descr="preencoded.png">    </p:cNvPr>
+          <p:cNvPr id="17" name="Image 6" descr="preencoded.png">    </p:cNvPr>
           <p:cNvPicPr>
             <a:picLocks noChangeAspect="1"/>
           </p:cNvPicPr>
@@ -10598,7 +10714,7 @@
       </p:pic>
       <p:sp>
         <p:nvSpPr>
-          <p:cNvPr id="17" name="Text 8"/>
+          <p:cNvPr id="18" name="Text 9"/>
           <p:cNvSpPr/>
           <p:nvPr/>
         </p:nvSpPr>
@@ -10637,7 +10753,7 @@
       </p:sp>
       <p:sp>
         <p:nvSpPr>
-          <p:cNvPr id="18" name="Text 9"/>
+          <p:cNvPr id="19" name="Text 10"/>
           <p:cNvSpPr/>
           <p:nvPr/>
         </p:nvSpPr>
@@ -10679,7 +10795,7 @@
       </p:sp>
       <p:sp>
         <p:nvSpPr>
-          <p:cNvPr id="19" name="Shape 10"/>
+          <p:cNvPr id="20" name="Shape 11"/>
           <p:cNvSpPr/>
           <p:nvPr/>
         </p:nvSpPr>
@@ -10708,7 +10824,7 @@
       </p:sp>
       <p:sp>
         <p:nvSpPr>
-          <p:cNvPr id="20" name="Shape 11"/>
+          <p:cNvPr id="21" name="Shape 12"/>
           <p:cNvSpPr/>
           <p:nvPr/>
         </p:nvSpPr>
@@ -10730,7 +10846,7 @@
       </p:sp>
       <p:sp>
         <p:nvSpPr>
-          <p:cNvPr id="21" name="Shape 12"/>
+          <p:cNvPr id="22" name="Shape 13"/>
           <p:cNvSpPr/>
           <p:nvPr/>
         </p:nvSpPr>
@@ -10752,7 +10868,7 @@
       </p:sp>
       <p:pic>
         <p:nvPicPr>
-          <p:cNvPr id="22" name="Image 7" descr="preencoded.png">    </p:cNvPr>
+          <p:cNvPr id="23" name="Image 7" descr="preencoded.png">    </p:cNvPr>
           <p:cNvPicPr>
             <a:picLocks noChangeAspect="1"/>
           </p:cNvPicPr>
@@ -10782,7 +10898,7 @@
       </p:pic>
       <p:sp>
         <p:nvSpPr>
-          <p:cNvPr id="23" name="Text 13"/>
+          <p:cNvPr id="24" name="Text 14"/>
           <p:cNvSpPr/>
           <p:nvPr/>
         </p:nvSpPr>
@@ -10821,7 +10937,7 @@
       </p:sp>
       <p:sp>
         <p:nvSpPr>
-          <p:cNvPr id="24" name="Text 14"/>
+          <p:cNvPr id="25" name="Text 15"/>
           <p:cNvSpPr/>
           <p:nvPr/>
         </p:nvSpPr>
@@ -10863,7 +10979,7 @@
       </p:sp>
       <p:sp>
         <p:nvSpPr>
-          <p:cNvPr id="25" name="Shape 15"/>
+          <p:cNvPr id="26" name="Shape 16"/>
           <p:cNvSpPr/>
           <p:nvPr/>
         </p:nvSpPr>
@@ -10892,7 +11008,7 @@
       </p:sp>
       <p:sp>
         <p:nvSpPr>
-          <p:cNvPr id="26" name="Shape 16"/>
+          <p:cNvPr id="27" name="Shape 17"/>
           <p:cNvSpPr/>
           <p:nvPr/>
         </p:nvSpPr>
@@ -10914,7 +11030,7 @@
       </p:sp>
       <p:sp>
         <p:nvSpPr>
-          <p:cNvPr id="27" name="Shape 17"/>
+          <p:cNvPr id="28" name="Shape 18"/>
           <p:cNvSpPr/>
           <p:nvPr/>
         </p:nvSpPr>
@@ -10936,7 +11052,7 @@
       </p:sp>
       <p:pic>
         <p:nvPicPr>
-          <p:cNvPr id="28" name="Image 8" descr="preencoded.png">    </p:cNvPr>
+          <p:cNvPr id="29" name="Image 8" descr="preencoded.png">    </p:cNvPr>
           <p:cNvPicPr>
             <a:picLocks noChangeAspect="1"/>
           </p:cNvPicPr>
@@ -10966,7 +11082,7 @@
       </p:pic>
       <p:sp>
         <p:nvSpPr>
-          <p:cNvPr id="29" name="Text 18"/>
+          <p:cNvPr id="30" name="Text 19"/>
           <p:cNvSpPr/>
           <p:nvPr/>
         </p:nvSpPr>
@@ -11005,7 +11121,7 @@
       </p:sp>
       <p:sp>
         <p:nvSpPr>
-          <p:cNvPr id="30" name="Text 19"/>
+          <p:cNvPr id="31" name="Text 20"/>
           <p:cNvSpPr/>
           <p:nvPr/>
         </p:nvSpPr>
@@ -11047,7 +11163,7 @@
       </p:sp>
       <p:pic>
         <p:nvPicPr>
-          <p:cNvPr id="31" name="Image 9" descr="preencoded.png">    </p:cNvPr>
+          <p:cNvPr id="32" name="Image 9" descr="preencoded.png">    </p:cNvPr>
           <p:cNvPicPr>
             <a:picLocks noChangeAspect="1"/>
           </p:cNvPicPr>
@@ -11077,7 +11193,7 @@
       </p:pic>
       <p:sp>
         <p:nvSpPr>
-          <p:cNvPr id="32" name="Text 20"/>
+          <p:cNvPr id="33" name="Text 21"/>
           <p:cNvSpPr/>
           <p:nvPr/>
         </p:nvSpPr>
@@ -11116,7 +11232,7 @@
       </p:sp>
       <p:sp>
         <p:nvSpPr>
-          <p:cNvPr id="33" name="Text 21"/>
+          <p:cNvPr id="34" name="Text 22"/>
           <p:cNvSpPr/>
           <p:nvPr/>
         </p:nvSpPr>
@@ -11179,7 +11295,7 @@
       </p:sp>
       <p:pic>
         <p:nvPicPr>
-          <p:cNvPr id="34" name="Image 10" descr="preencoded.png">    </p:cNvPr>
+          <p:cNvPr id="35" name="Image 10" descr="preencoded.png">    </p:cNvPr>
           <p:cNvPicPr>
             <a:picLocks noChangeAspect="1"/>
           </p:cNvPicPr>
@@ -11209,7 +11325,7 @@
       </p:pic>
       <p:sp>
         <p:nvSpPr>
-          <p:cNvPr id="35" name="Text 22"/>
+          <p:cNvPr id="36" name="Text 23"/>
           <p:cNvSpPr/>
           <p:nvPr/>
         </p:nvSpPr>
@@ -11248,7 +11364,7 @@
       </p:sp>
       <p:sp>
         <p:nvSpPr>
-          <p:cNvPr id="36" name="Text 23"/>
+          <p:cNvPr id="37" name="Text 24"/>
           <p:cNvSpPr/>
           <p:nvPr/>
         </p:nvSpPr>
@@ -11287,7 +11403,7 @@
       </p:sp>
       <p:sp>
         <p:nvSpPr>
-          <p:cNvPr id="37" name="Text 24"/>
+          <p:cNvPr id="38" name="Text 25"/>
           <p:cNvSpPr/>
           <p:nvPr/>
         </p:nvSpPr>
@@ -11326,7 +11442,7 @@
       </p:sp>
       <p:sp>
         <p:nvSpPr>
-          <p:cNvPr id="38" name="Text 25"/>
+          <p:cNvPr id="39" name="Text 26"/>
           <p:cNvSpPr/>
           <p:nvPr/>
         </p:nvSpPr>

</xml_diff>

<commit_message>
Fix timeline readability on Wende slide (cathedral background)
- Add dark panel behind entire right-column timeline (cx to right edge)
  so red cathedral photo no longer bleeds through the text
- Add black drop shadows on all year labels and event text items

https://claude.ai/code/session_013TBMzPSrUf2jGzKeLXb52a
</commit_message>
<xml_diff>
--- a/Anfaenge_Kirche_Antike_v3.pptx
+++ b/Anfaenge_Kirche_Antike_v3.pptx
@@ -10385,7 +10385,36 @@
       </p:sp>
       <p:sp>
         <p:nvSpPr>
-          <p:cNvPr id="15" name="Text 8"/>
+          <p:cNvPr id="15" name="Shape 8"/>
+          <p:cNvSpPr/>
+          <p:nvPr/>
+        </p:nvSpPr>
+        <p:spPr>
+          <a:xfrm>
+            <a:off x="6248242" y="182880"/>
+            <a:ext cx="5925166" cy="6601968"/>
+          </a:xfrm>
+          <a:prstGeom prst="rect">
+            <a:avLst/>
+          </a:prstGeom>
+          <a:solidFill>
+            <a:srgbClr val="000000">
+              <a:alpha val="38000"/>
+            </a:srgbClr>
+          </a:solidFill>
+          <a:ln w="12700">
+            <a:solidFill>
+              <a:srgbClr val="000000">
+                <a:alpha val="0"/>
+              </a:srgbClr>
+            </a:solidFill>
+            <a:prstDash val="solid"/>
+          </a:ln>
+        </p:spPr>
+      </p:sp>
+      <p:sp>
+        <p:nvSpPr>
+          <p:cNvPr id="16" name="Text 9"/>
           <p:cNvSpPr/>
           <p:nvPr/>
         </p:nvSpPr>
@@ -10424,7 +10453,7 @@
       </p:sp>
       <p:pic>
         <p:nvPicPr>
-          <p:cNvPr id="16" name="Image 5" descr="preencoded.png">    </p:cNvPr>
+          <p:cNvPr id="17" name="Image 5" descr="preencoded.png">    </p:cNvPr>
           <p:cNvPicPr>
             <a:picLocks noChangeAspect="1"/>
           </p:cNvPicPr>
@@ -10454,7 +10483,7 @@
       </p:pic>
       <p:sp>
         <p:nvSpPr>
-          <p:cNvPr id="17" name="Shape 9"/>
+          <p:cNvPr id="18" name="Shape 10"/>
           <p:cNvSpPr/>
           <p:nvPr/>
         </p:nvSpPr>
@@ -10477,7 +10506,7 @@
       </p:sp>
       <p:sp>
         <p:nvSpPr>
-          <p:cNvPr id="18" name="Text 10"/>
+          <p:cNvPr id="19" name="Text 11"/>
           <p:cNvSpPr/>
           <p:nvPr/>
         </p:nvSpPr>
@@ -10491,6 +10520,13 @@
           </a:prstGeom>
           <a:noFill/>
           <a:ln/>
+          <a:effectLst>
+            <a:outerShdw sx="100000" sy="100000" kx="0" ky="0" algn="bl" rotWithShape="0" blurRad="76200" dist="50800" dir="16200000">
+              <a:srgbClr val="000000">
+                <a:alpha val="75000"/>
+              </a:srgbClr>
+            </a:outerShdw>
+          </a:effectLst>
         </p:spPr>
         <p:txBody>
           <a:bodyPr wrap="square" rtlCol="0" anchor="ctr"/>
@@ -10516,7 +10552,7 @@
       </p:sp>
       <p:sp>
         <p:nvSpPr>
-          <p:cNvPr id="19" name="Text 11"/>
+          <p:cNvPr id="20" name="Text 12"/>
           <p:cNvSpPr/>
           <p:nvPr/>
         </p:nvSpPr>
@@ -10530,6 +10566,13 @@
           </a:prstGeom>
           <a:noFill/>
           <a:ln/>
+          <a:effectLst>
+            <a:outerShdw sx="100000" sy="100000" kx="0" ky="0" algn="bl" rotWithShape="0" blurRad="63500" dist="50800" dir="16200000">
+              <a:srgbClr val="000000">
+                <a:alpha val="75000"/>
+              </a:srgbClr>
+            </a:outerShdw>
+          </a:effectLst>
         </p:spPr>
         <p:txBody>
           <a:bodyPr wrap="square" rtlCol="0" anchor="ctr"/>
@@ -10558,7 +10601,7 @@
       </p:sp>
       <p:pic>
         <p:nvPicPr>
-          <p:cNvPr id="20" name="Image 6" descr="preencoded.png">    </p:cNvPr>
+          <p:cNvPr id="21" name="Image 6" descr="preencoded.png">    </p:cNvPr>
           <p:cNvPicPr>
             <a:picLocks noChangeAspect="1"/>
           </p:cNvPicPr>
@@ -10588,7 +10631,7 @@
       </p:pic>
       <p:sp>
         <p:nvSpPr>
-          <p:cNvPr id="21" name="Shape 12"/>
+          <p:cNvPr id="22" name="Shape 13"/>
           <p:cNvSpPr/>
           <p:nvPr/>
         </p:nvSpPr>
@@ -10611,7 +10654,7 @@
       </p:sp>
       <p:sp>
         <p:nvSpPr>
-          <p:cNvPr id="22" name="Text 13"/>
+          <p:cNvPr id="23" name="Text 14"/>
           <p:cNvSpPr/>
           <p:nvPr/>
         </p:nvSpPr>
@@ -10625,6 +10668,13 @@
           </a:prstGeom>
           <a:noFill/>
           <a:ln/>
+          <a:effectLst>
+            <a:outerShdw sx="100000" sy="100000" kx="0" ky="0" algn="bl" rotWithShape="0" blurRad="76200" dist="50800" dir="16200000">
+              <a:srgbClr val="000000">
+                <a:alpha val="75000"/>
+              </a:srgbClr>
+            </a:outerShdw>
+          </a:effectLst>
         </p:spPr>
         <p:txBody>
           <a:bodyPr wrap="square" rtlCol="0" anchor="ctr"/>
@@ -10650,7 +10700,7 @@
       </p:sp>
       <p:sp>
         <p:nvSpPr>
-          <p:cNvPr id="23" name="Text 14"/>
+          <p:cNvPr id="24" name="Text 15"/>
           <p:cNvSpPr/>
           <p:nvPr/>
         </p:nvSpPr>
@@ -10664,6 +10714,13 @@
           </a:prstGeom>
           <a:noFill/>
           <a:ln/>
+          <a:effectLst>
+            <a:outerShdw sx="100000" sy="100000" kx="0" ky="0" algn="bl" rotWithShape="0" blurRad="63500" dist="50800" dir="16200000">
+              <a:srgbClr val="000000">
+                <a:alpha val="75000"/>
+              </a:srgbClr>
+            </a:outerShdw>
+          </a:effectLst>
         </p:spPr>
         <p:txBody>
           <a:bodyPr wrap="square" rtlCol="0" anchor="ctr"/>
@@ -10692,7 +10749,7 @@
       </p:sp>
       <p:pic>
         <p:nvPicPr>
-          <p:cNvPr id="24" name="Image 7" descr="preencoded.png">    </p:cNvPr>
+          <p:cNvPr id="25" name="Image 7" descr="preencoded.png">    </p:cNvPr>
           <p:cNvPicPr>
             <a:picLocks noChangeAspect="1"/>
           </p:cNvPicPr>
@@ -10722,7 +10779,7 @@
       </p:pic>
       <p:sp>
         <p:nvSpPr>
-          <p:cNvPr id="25" name="Shape 15"/>
+          <p:cNvPr id="26" name="Shape 16"/>
           <p:cNvSpPr/>
           <p:nvPr/>
         </p:nvSpPr>
@@ -10745,7 +10802,7 @@
       </p:sp>
       <p:sp>
         <p:nvSpPr>
-          <p:cNvPr id="26" name="Text 16"/>
+          <p:cNvPr id="27" name="Text 17"/>
           <p:cNvSpPr/>
           <p:nvPr/>
         </p:nvSpPr>
@@ -10759,6 +10816,13 @@
           </a:prstGeom>
           <a:noFill/>
           <a:ln/>
+          <a:effectLst>
+            <a:outerShdw sx="100000" sy="100000" kx="0" ky="0" algn="bl" rotWithShape="0" blurRad="76200" dist="50800" dir="16200000">
+              <a:srgbClr val="000000">
+                <a:alpha val="75000"/>
+              </a:srgbClr>
+            </a:outerShdw>
+          </a:effectLst>
         </p:spPr>
         <p:txBody>
           <a:bodyPr wrap="square" rtlCol="0" anchor="ctr"/>
@@ -10784,7 +10848,7 @@
       </p:sp>
       <p:sp>
         <p:nvSpPr>
-          <p:cNvPr id="27" name="Text 17"/>
+          <p:cNvPr id="28" name="Text 18"/>
           <p:cNvSpPr/>
           <p:nvPr/>
         </p:nvSpPr>
@@ -10798,6 +10862,13 @@
           </a:prstGeom>
           <a:noFill/>
           <a:ln/>
+          <a:effectLst>
+            <a:outerShdw sx="100000" sy="100000" kx="0" ky="0" algn="bl" rotWithShape="0" blurRad="63500" dist="50800" dir="16200000">
+              <a:srgbClr val="000000">
+                <a:alpha val="75000"/>
+              </a:srgbClr>
+            </a:outerShdw>
+          </a:effectLst>
         </p:spPr>
         <p:txBody>
           <a:bodyPr wrap="square" rtlCol="0" anchor="ctr"/>
@@ -10826,7 +10897,7 @@
       </p:sp>
       <p:pic>
         <p:nvPicPr>
-          <p:cNvPr id="28" name="Image 8" descr="preencoded.png">    </p:cNvPr>
+          <p:cNvPr id="29" name="Image 8" descr="preencoded.png">    </p:cNvPr>
           <p:cNvPicPr>
             <a:picLocks noChangeAspect="1"/>
           </p:cNvPicPr>
@@ -10856,7 +10927,7 @@
       </p:pic>
       <p:sp>
         <p:nvSpPr>
-          <p:cNvPr id="29" name="Shape 18"/>
+          <p:cNvPr id="30" name="Shape 19"/>
           <p:cNvSpPr/>
           <p:nvPr/>
         </p:nvSpPr>
@@ -10879,7 +10950,7 @@
       </p:sp>
       <p:sp>
         <p:nvSpPr>
-          <p:cNvPr id="30" name="Text 19"/>
+          <p:cNvPr id="31" name="Text 20"/>
           <p:cNvSpPr/>
           <p:nvPr/>
         </p:nvSpPr>
@@ -10893,6 +10964,13 @@
           </a:prstGeom>
           <a:noFill/>
           <a:ln/>
+          <a:effectLst>
+            <a:outerShdw sx="100000" sy="100000" kx="0" ky="0" algn="bl" rotWithShape="0" blurRad="76200" dist="50800" dir="16200000">
+              <a:srgbClr val="000000">
+                <a:alpha val="75000"/>
+              </a:srgbClr>
+            </a:outerShdw>
+          </a:effectLst>
         </p:spPr>
         <p:txBody>
           <a:bodyPr wrap="square" rtlCol="0" anchor="ctr"/>
@@ -10918,7 +10996,7 @@
       </p:sp>
       <p:sp>
         <p:nvSpPr>
-          <p:cNvPr id="31" name="Text 20"/>
+          <p:cNvPr id="32" name="Text 21"/>
           <p:cNvSpPr/>
           <p:nvPr/>
         </p:nvSpPr>
@@ -10932,6 +11010,13 @@
           </a:prstGeom>
           <a:noFill/>
           <a:ln/>
+          <a:effectLst>
+            <a:outerShdw sx="100000" sy="100000" kx="0" ky="0" algn="bl" rotWithShape="0" blurRad="63500" dist="50800" dir="16200000">
+              <a:srgbClr val="000000">
+                <a:alpha val="75000"/>
+              </a:srgbClr>
+            </a:outerShdw>
+          </a:effectLst>
         </p:spPr>
         <p:txBody>
           <a:bodyPr wrap="square" rtlCol="0" anchor="ctr"/>
@@ -10960,7 +11045,7 @@
       </p:sp>
       <p:pic>
         <p:nvPicPr>
-          <p:cNvPr id="32" name="Image 9" descr="preencoded.png">    </p:cNvPr>
+          <p:cNvPr id="33" name="Image 9" descr="preencoded.png">    </p:cNvPr>
           <p:cNvPicPr>
             <a:picLocks noChangeAspect="1"/>
           </p:cNvPicPr>
@@ -10990,7 +11075,7 @@
       </p:pic>
       <p:sp>
         <p:nvSpPr>
-          <p:cNvPr id="33" name="Shape 21"/>
+          <p:cNvPr id="34" name="Shape 22"/>
           <p:cNvSpPr/>
           <p:nvPr/>
         </p:nvSpPr>
@@ -11013,7 +11098,7 @@
       </p:sp>
       <p:sp>
         <p:nvSpPr>
-          <p:cNvPr id="34" name="Text 22"/>
+          <p:cNvPr id="35" name="Text 23"/>
           <p:cNvSpPr/>
           <p:nvPr/>
         </p:nvSpPr>
@@ -11027,6 +11112,13 @@
           </a:prstGeom>
           <a:noFill/>
           <a:ln/>
+          <a:effectLst>
+            <a:outerShdw sx="100000" sy="100000" kx="0" ky="0" algn="bl" rotWithShape="0" blurRad="76200" dist="50800" dir="16200000">
+              <a:srgbClr val="000000">
+                <a:alpha val="75000"/>
+              </a:srgbClr>
+            </a:outerShdw>
+          </a:effectLst>
         </p:spPr>
         <p:txBody>
           <a:bodyPr wrap="square" rtlCol="0" anchor="ctr"/>
@@ -11052,7 +11144,7 @@
       </p:sp>
       <p:sp>
         <p:nvSpPr>
-          <p:cNvPr id="35" name="Text 23"/>
+          <p:cNvPr id="36" name="Text 24"/>
           <p:cNvSpPr/>
           <p:nvPr/>
         </p:nvSpPr>
@@ -11066,6 +11158,13 @@
           </a:prstGeom>
           <a:noFill/>
           <a:ln/>
+          <a:effectLst>
+            <a:outerShdw sx="100000" sy="100000" kx="0" ky="0" algn="bl" rotWithShape="0" blurRad="63500" dist="50800" dir="16200000">
+              <a:srgbClr val="000000">
+                <a:alpha val="75000"/>
+              </a:srgbClr>
+            </a:outerShdw>
+          </a:effectLst>
         </p:spPr>
         <p:txBody>
           <a:bodyPr wrap="square" rtlCol="0" anchor="ctr"/>
@@ -11094,7 +11193,7 @@
       </p:sp>
       <p:pic>
         <p:nvPicPr>
-          <p:cNvPr id="36" name="Image 10" descr="preencoded.png">    </p:cNvPr>
+          <p:cNvPr id="37" name="Image 10" descr="preencoded.png">    </p:cNvPr>
           <p:cNvPicPr>
             <a:picLocks noChangeAspect="1"/>
           </p:cNvPicPr>
@@ -11124,7 +11223,7 @@
       </p:pic>
       <p:sp>
         <p:nvSpPr>
-          <p:cNvPr id="37" name="Shape 24"/>
+          <p:cNvPr id="38" name="Shape 25"/>
           <p:cNvSpPr/>
           <p:nvPr/>
         </p:nvSpPr>
@@ -11147,7 +11246,7 @@
       </p:sp>
       <p:sp>
         <p:nvSpPr>
-          <p:cNvPr id="38" name="Text 25"/>
+          <p:cNvPr id="39" name="Text 26"/>
           <p:cNvSpPr/>
           <p:nvPr/>
         </p:nvSpPr>
@@ -11161,6 +11260,13 @@
           </a:prstGeom>
           <a:noFill/>
           <a:ln/>
+          <a:effectLst>
+            <a:outerShdw sx="100000" sy="100000" kx="0" ky="0" algn="bl" rotWithShape="0" blurRad="76200" dist="50800" dir="16200000">
+              <a:srgbClr val="000000">
+                <a:alpha val="75000"/>
+              </a:srgbClr>
+            </a:outerShdw>
+          </a:effectLst>
         </p:spPr>
         <p:txBody>
           <a:bodyPr wrap="square" rtlCol="0" anchor="ctr"/>
@@ -11186,7 +11292,7 @@
       </p:sp>
       <p:sp>
         <p:nvSpPr>
-          <p:cNvPr id="39" name="Text 26"/>
+          <p:cNvPr id="40" name="Text 27"/>
           <p:cNvSpPr/>
           <p:nvPr/>
         </p:nvSpPr>
@@ -11200,6 +11306,13 @@
           </a:prstGeom>
           <a:noFill/>
           <a:ln/>
+          <a:effectLst>
+            <a:outerShdw sx="100000" sy="100000" kx="0" ky="0" algn="bl" rotWithShape="0" blurRad="63500" dist="50800" dir="16200000">
+              <a:srgbClr val="000000">
+                <a:alpha val="75000"/>
+              </a:srgbClr>
+            </a:outerShdw>
+          </a:effectLst>
         </p:spPr>
         <p:txBody>
           <a:bodyPr wrap="square" rtlCol="0" anchor="ctr"/>
@@ -11228,7 +11341,7 @@
       </p:sp>
       <p:pic>
         <p:nvPicPr>
-          <p:cNvPr id="40" name="Image 11" descr="preencoded.png">    </p:cNvPr>
+          <p:cNvPr id="41" name="Image 11" descr="preencoded.png">    </p:cNvPr>
           <p:cNvPicPr>
             <a:picLocks noChangeAspect="1"/>
           </p:cNvPicPr>
@@ -11258,7 +11371,7 @@
       </p:pic>
       <p:sp>
         <p:nvSpPr>
-          <p:cNvPr id="41" name="Text 27"/>
+          <p:cNvPr id="42" name="Text 28"/>
           <p:cNvSpPr/>
           <p:nvPr/>
         </p:nvSpPr>
@@ -11272,6 +11385,13 @@
           </a:prstGeom>
           <a:noFill/>
           <a:ln/>
+          <a:effectLst>
+            <a:outerShdw sx="100000" sy="100000" kx="0" ky="0" algn="bl" rotWithShape="0" blurRad="76200" dist="50800" dir="16200000">
+              <a:srgbClr val="000000">
+                <a:alpha val="75000"/>
+              </a:srgbClr>
+            </a:outerShdw>
+          </a:effectLst>
         </p:spPr>
         <p:txBody>
           <a:bodyPr wrap="square" rtlCol="0" anchor="ctr"/>
@@ -11297,7 +11417,7 @@
       </p:sp>
       <p:sp>
         <p:nvSpPr>
-          <p:cNvPr id="42" name="Text 28"/>
+          <p:cNvPr id="43" name="Text 29"/>
           <p:cNvSpPr/>
           <p:nvPr/>
         </p:nvSpPr>
@@ -11311,6 +11431,13 @@
           </a:prstGeom>
           <a:noFill/>
           <a:ln/>
+          <a:effectLst>
+            <a:outerShdw sx="100000" sy="100000" kx="0" ky="0" algn="bl" rotWithShape="0" blurRad="63500" dist="50800" dir="16200000">
+              <a:srgbClr val="000000">
+                <a:alpha val="75000"/>
+              </a:srgbClr>
+            </a:outerShdw>
+          </a:effectLst>
         </p:spPr>
         <p:txBody>
           <a:bodyPr wrap="square" rtlCol="0" anchor="ctr"/>

</xml_diff>